<commit_message>
docs(alpha): slides com prints do APK e da web, fotos da demonstração e 314 testes
</commit_message>
<xml_diff>
--- a/Achei_um_Bicho_Alpha.pptx
+++ b/Achei_um_Bicho_Alpha.pptx
@@ -5909,7 +5909,7 @@
         <p:spPr>
           <a:xfrm>
             <a:off x="685800" y="566928"/>
-            <a:ext cx="2645043" cy="5724144"/>
+            <a:ext cx="2641913" cy="5724144"/>
           </a:xfrm>
           <a:prstGeom prst="rect">
             <a:avLst/>
@@ -6409,7 +6409,7 @@
         <p:spPr>
           <a:xfrm>
             <a:off x="685800" y="566928"/>
-            <a:ext cx="2645043" cy="5724144"/>
+            <a:ext cx="2641913" cy="5724144"/>
           </a:xfrm>
           <a:prstGeom prst="rect">
             <a:avLst/>
@@ -6433,7 +6433,7 @@
         <p:spPr>
           <a:xfrm>
             <a:off x="3742322" y="566928"/>
-            <a:ext cx="2645043" cy="5724144"/>
+            <a:ext cx="2641913" cy="5724144"/>
           </a:xfrm>
           <a:prstGeom prst="rect">
             <a:avLst/>
@@ -6986,7 +6986,7 @@
         <p:spPr>
           <a:xfrm>
             <a:off x="685800" y="566928"/>
-            <a:ext cx="2645043" cy="5724144"/>
+            <a:ext cx="2641913" cy="5724144"/>
           </a:xfrm>
           <a:prstGeom prst="rect">
             <a:avLst/>
@@ -7010,7 +7010,7 @@
         <p:spPr>
           <a:xfrm>
             <a:off x="3742322" y="566928"/>
-            <a:ext cx="2645043" cy="5724144"/>
+            <a:ext cx="2644545" cy="5724144"/>
           </a:xfrm>
           <a:prstGeom prst="rect">
             <a:avLst/>
@@ -7510,7 +7510,7 @@
         <p:spPr>
           <a:xfrm>
             <a:off x="685800" y="566928"/>
-            <a:ext cx="2645043" cy="5724144"/>
+            <a:ext cx="2644545" cy="5724144"/>
           </a:xfrm>
           <a:prstGeom prst="rect">
             <a:avLst/>
@@ -7534,7 +7534,7 @@
         <p:spPr>
           <a:xfrm>
             <a:off x="3742322" y="566928"/>
-            <a:ext cx="2645043" cy="5724144"/>
+            <a:ext cx="2644545" cy="5724144"/>
           </a:xfrm>
           <a:prstGeom prst="rect">
             <a:avLst/>
@@ -9903,7 +9903,7 @@
                 </a:solidFill>
                 <a:latin typeface="Commissioner"/>
               </a:rPr>
-              <a:t>286 testes automáticos</a:t>
+              <a:t>314 testes automáticos</a:t>
             </a:r>
           </a:p>
         </p:txBody>
@@ -10108,7 +10108,7 @@
                 </a:solidFill>
                 <a:latin typeface="Commissioner"/>
               </a:rPr>
-              <a:t>55</a:t>
+              <a:t>75</a:t>
             </a:r>
           </a:p>
         </p:txBody>
@@ -10352,7 +10352,7 @@
                 </a:solidFill>
                 <a:latin typeface="Commissioner"/>
               </a:rPr>
-              <a:t>89</a:t>
+              <a:t>97</a:t>
             </a:r>
           </a:p>
         </p:txBody>

</xml_diff>

<commit_message>
docs(alpha): slide do caso aberto com o mapa que abre no Google Maps, 316 testes
</commit_message>
<xml_diff>
--- a/Achei_um_Bicho_Alpha.pptx
+++ b/Achei_um_Bicho_Alpha.pptx
@@ -6986,7 +6986,7 @@
         <p:spPr>
           <a:xfrm>
             <a:off x="685800" y="566928"/>
-            <a:ext cx="2641913" cy="5724144"/>
+            <a:ext cx="2644545" cy="5724144"/>
           </a:xfrm>
           <a:prstGeom prst="rect">
             <a:avLst/>
@@ -7173,7 +7173,7 @@
                 </a:solidFill>
                 <a:latin typeface="IBM Plex Sans"/>
               </a:rPr>
-              <a:t>O mapa mostra uma área aproximada, sempre o mesmo círculo, nunca a casa de ninguém.</a:t>
+              <a:t>O mapa mostra uma área aproximada, sempre o mesmo círculo; tocar abre no Google Maps, sem pino.</a:t>
             </a:r>
           </a:p>
         </p:txBody>
@@ -9903,7 +9903,7 @@
                 </a:solidFill>
                 <a:latin typeface="Commissioner"/>
               </a:rPr>
-              <a:t>314 testes automáticos</a:t>
+              <a:t>316 testes automáticos</a:t>
             </a:r>
           </a:p>
         </p:txBody>
@@ -10352,7 +10352,7 @@
                 </a:solidFill>
                 <a:latin typeface="Commissioner"/>
               </a:rPr>
-              <a:t>97</a:t>
+              <a:t>99</a:t>
             </a:r>
           </a:p>
         </p:txBody>

</xml_diff>

<commit_message>
docs(alpha): slides com 319 testes
</commit_message>
<xml_diff>
--- a/Achei_um_Bicho_Alpha.pptx
+++ b/Achei_um_Bicho_Alpha.pptx
@@ -9903,7 +9903,7 @@
                 </a:solidFill>
                 <a:latin typeface="Commissioner"/>
               </a:rPr>
-              <a:t>316 testes automáticos</a:t>
+              <a:t>319 testes automáticos</a:t>
             </a:r>
           </a:p>
         </p:txBody>
@@ -10352,7 +10352,7 @@
                 </a:solidFill>
                 <a:latin typeface="Commissioner"/>
               </a:rPr>
-              <a:t>99</a:t>
+              <a:t>102</a:t>
             </a:r>
           </a:p>
         </p:txBody>

</xml_diff>